<commit_message>
Update Abigail weekly report
</commit_message>
<xml_diff>
--- a/Weekly Reports/slides/4-abigail-duran.pptx
+++ b/Weekly Reports/slides/4-abigail-duran.pptx
@@ -5,7 +5,7 @@
     <p:sldMasterId id="2147483648" r:id="rId1"/>
   </p:sldMasterIdLst>
   <p:sldIdLst>
-    <p:sldId id="257" r:id="rId3"/>
+    <p:sldId id="257" r:id="rId2"/>
   </p:sldIdLst>
   <p:sldSz cx="12192000" cy="6858000"/>
   <p:notesSz cx="6858000" cy="9144000"/>
@@ -259,7 +259,7 @@
           <a:p>
             <a:fld id="{752E6B35-DAD5-CF47-9E65-9CA12B499D8C}" type="datetimeFigureOut">
               <a:rPr lang="en-US" smtClean="0"/>
-              <a:t>9/14/2026</a:t>
+              <a:t>9/14/26</a:t>
             </a:fld>
             <a:endParaRPr lang="en-US"/>
           </a:p>
@@ -457,7 +457,7 @@
           <a:p>
             <a:fld id="{752E6B35-DAD5-CF47-9E65-9CA12B499D8C}" type="datetimeFigureOut">
               <a:rPr lang="en-US" smtClean="0"/>
-              <a:t>9/14/2026</a:t>
+              <a:t>9/14/26</a:t>
             </a:fld>
             <a:endParaRPr lang="en-US"/>
           </a:p>
@@ -665,7 +665,7 @@
           <a:p>
             <a:fld id="{752E6B35-DAD5-CF47-9E65-9CA12B499D8C}" type="datetimeFigureOut">
               <a:rPr lang="en-US" smtClean="0"/>
-              <a:t>9/14/2026</a:t>
+              <a:t>9/14/26</a:t>
             </a:fld>
             <a:endParaRPr lang="en-US"/>
           </a:p>
@@ -863,7 +863,7 @@
           <a:p>
             <a:fld id="{752E6B35-DAD5-CF47-9E65-9CA12B499D8C}" type="datetimeFigureOut">
               <a:rPr lang="en-US" smtClean="0"/>
-              <a:t>9/14/2026</a:t>
+              <a:t>9/14/26</a:t>
             </a:fld>
             <a:endParaRPr lang="en-US"/>
           </a:p>
@@ -1138,7 +1138,7 @@
           <a:p>
             <a:fld id="{752E6B35-DAD5-CF47-9E65-9CA12B499D8C}" type="datetimeFigureOut">
               <a:rPr lang="en-US" smtClean="0"/>
-              <a:t>9/14/2026</a:t>
+              <a:t>9/14/26</a:t>
             </a:fld>
             <a:endParaRPr lang="en-US"/>
           </a:p>
@@ -1403,7 +1403,7 @@
           <a:p>
             <a:fld id="{752E6B35-DAD5-CF47-9E65-9CA12B499D8C}" type="datetimeFigureOut">
               <a:rPr lang="en-US" smtClean="0"/>
-              <a:t>9/14/2026</a:t>
+              <a:t>9/14/26</a:t>
             </a:fld>
             <a:endParaRPr lang="en-US"/>
           </a:p>
@@ -1815,7 +1815,7 @@
           <a:p>
             <a:fld id="{752E6B35-DAD5-CF47-9E65-9CA12B499D8C}" type="datetimeFigureOut">
               <a:rPr lang="en-US" smtClean="0"/>
-              <a:t>9/14/2026</a:t>
+              <a:t>9/14/26</a:t>
             </a:fld>
             <a:endParaRPr lang="en-US"/>
           </a:p>
@@ -1956,7 +1956,7 @@
           <a:p>
             <a:fld id="{752E6B35-DAD5-CF47-9E65-9CA12B499D8C}" type="datetimeFigureOut">
               <a:rPr lang="en-US" smtClean="0"/>
-              <a:t>9/14/2026</a:t>
+              <a:t>9/14/26</a:t>
             </a:fld>
             <a:endParaRPr lang="en-US"/>
           </a:p>
@@ -2069,7 +2069,7 @@
           <a:p>
             <a:fld id="{752E6B35-DAD5-CF47-9E65-9CA12B499D8C}" type="datetimeFigureOut">
               <a:rPr lang="en-US" smtClean="0"/>
-              <a:t>9/14/2026</a:t>
+              <a:t>9/14/26</a:t>
             </a:fld>
             <a:endParaRPr lang="en-US"/>
           </a:p>
@@ -2380,7 +2380,7 @@
           <a:p>
             <a:fld id="{752E6B35-DAD5-CF47-9E65-9CA12B499D8C}" type="datetimeFigureOut">
               <a:rPr lang="en-US" smtClean="0"/>
-              <a:t>9/14/2026</a:t>
+              <a:t>9/14/26</a:t>
             </a:fld>
             <a:endParaRPr lang="en-US"/>
           </a:p>
@@ -2668,7 +2668,7 @@
           <a:p>
             <a:fld id="{752E6B35-DAD5-CF47-9E65-9CA12B499D8C}" type="datetimeFigureOut">
               <a:rPr lang="en-US" smtClean="0"/>
-              <a:t>9/14/2026</a:t>
+              <a:t>9/14/26</a:t>
             </a:fld>
             <a:endParaRPr lang="en-US"/>
           </a:p>
@@ -2909,7 +2909,7 @@
           <a:p>
             <a:fld id="{752E6B35-DAD5-CF47-9E65-9CA12B499D8C}" type="datetimeFigureOut">
               <a:rPr lang="en-US" smtClean="0"/>
-              <a:t>9/14/2026</a:t>
+              <a:t>9/14/26</a:t>
             </a:fld>
             <a:endParaRPr lang="en-US"/>
           </a:p>
@@ -3377,61 +3377,119 @@
         </p:spPr>
         <p:txBody>
           <a:bodyPr>
-            <a:normAutofit fontScale="85000" lnSpcReduction="20000"/>
+            <a:normAutofit fontScale="62500" lnSpcReduction="20000"/>
           </a:bodyPr>
           <a:lstStyle/>
           <a:p>
-            <a:pPr/>
-            <a:r>
-              <a:rPr b="1"/>
+            <a:r>
+              <a:rPr b="1" dirty="0"/>
               <a:t>Goals for the week</a:t>
             </a:r>
+            <a:endParaRPr lang="en-US" b="1" dirty="0"/>
+          </a:p>
+          <a:p>
+            <a:pPr lvl="1"/>
+            <a:r>
+              <a:rPr lang="en-US" dirty="0"/>
+              <a:t>Finalize the list of PCB requirements for the stationary testing system.​</a:t>
+            </a:r>
+          </a:p>
+          <a:p>
+            <a:pPr lvl="1"/>
+            <a:r>
+              <a:rPr lang="en-US" dirty="0"/>
+              <a:t>Determine the major components, connections, and power requirements needed for PCB design.​</a:t>
+            </a:r>
+          </a:p>
+          <a:p>
+            <a:pPr lvl="1"/>
             <a:endParaRPr lang="en-US" dirty="0"/>
           </a:p>
           <a:p>
+            <a:r>
+              <a:rPr b="1" dirty="0"/>
+              <a:t>Progress for the week</a:t>
+            </a:r>
+          </a:p>
+          <a:p>
             <a:pPr lvl="1"/>
             <a:r>
-              <a:t/>
-            </a:r>
-          </a:p>
-          <a:p>
-            <a:pPr/>
-            <a:r>
-              <a:rPr b="1"/>
-              <a:t>Progress for the week</a:t>
+              <a:rPr lang="en-US" dirty="0"/>
+              <a:t>Completed the first-semester schematic for stationary testing of the autonomous car system.​</a:t>
             </a:r>
           </a:p>
           <a:p>
             <a:pPr lvl="1"/>
             <a:r>
-              <a:t/>
-            </a:r>
-          </a:p>
-          <a:p>
-            <a:pPr/>
-            <a:r>
-              <a:rPr b="1"/>
+              <a:rPr lang="en-US" dirty="0"/>
+              <a:t>Built and refined the schematic around the Raspberry Pi Compute Module 5.​</a:t>
+            </a:r>
+          </a:p>
+          <a:p>
+            <a:pPr lvl="1"/>
+            <a:r>
+              <a:rPr lang="en-US" dirty="0"/>
+              <a:t>Resolved schematic/ERC issues and prepared the design for PCB development.​</a:t>
+            </a:r>
+          </a:p>
+          <a:p>
+            <a:pPr lvl="1"/>
+            <a:r>
+              <a:rPr lang="en-US" dirty="0"/>
+              <a:t>Began hardware prototyping for the stationary testing setup.​</a:t>
+            </a:r>
+          </a:p>
+          <a:p>
+            <a:pPr lvl="1"/>
+            <a:endParaRPr b="1" dirty="0"/>
+          </a:p>
+          <a:p>
+            <a:r>
+              <a:rPr b="1" dirty="0"/>
               <a:t>Goals for next week</a:t>
             </a:r>
           </a:p>
           <a:p>
             <a:pPr lvl="1"/>
             <a:r>
-              <a:t/>
-            </a:r>
-          </a:p>
-          <a:p>
-            <a:pPr/>
-            <a:r>
-              <a:rPr b="1"/>
+              <a:rPr lang="en-US" dirty="0"/>
+              <a:t>Begin the PCB design and layout using the completed schematic.​</a:t>
+            </a:r>
+          </a:p>
+          <a:p>
+            <a:pPr lvl="1"/>
+            <a:r>
+              <a:rPr lang="en-US" dirty="0"/>
+              <a:t>Start placing major components and determining board dimensions.​</a:t>
+            </a:r>
+          </a:p>
+          <a:p>
+            <a:pPr lvl="1"/>
+            <a:r>
+              <a:rPr lang="en-US" dirty="0"/>
+              <a:t>Begin planning power and signal routing.​</a:t>
+            </a:r>
+          </a:p>
+          <a:p>
+            <a:pPr lvl="1"/>
+            <a:endParaRPr b="1" dirty="0"/>
+          </a:p>
+          <a:p>
+            <a:r>
+              <a:rPr b="1" dirty="0"/>
               <a:t>Hours spent on progress</a:t>
             </a:r>
           </a:p>
           <a:p>
             <a:pPr lvl="1"/>
             <a:r>
-              <a:t/>
-            </a:r>
+              <a:rPr lang="en-US" dirty="0"/>
+              <a:t>6 hours​</a:t>
+            </a:r>
+          </a:p>
+          <a:p>
+            <a:pPr lvl="1"/>
+            <a:endParaRPr b="1" dirty="0"/>
           </a:p>
         </p:txBody>
       </p:sp>

</xml_diff>

<commit_message>
Week 5 Slide Updates
</commit_message>
<xml_diff>
--- a/Weekly Reports/slides/4-abigail-duran.pptx
+++ b/Weekly Reports/slides/4-abigail-duran.pptx
@@ -259,7 +259,7 @@
           <a:p>
             <a:fld id="{752E6B35-DAD5-CF47-9E65-9CA12B499D8C}" type="datetimeFigureOut">
               <a:rPr lang="en-US" smtClean="0"/>
-              <a:t>9/14/26</a:t>
+              <a:t>9/22/26</a:t>
             </a:fld>
             <a:endParaRPr lang="en-US"/>
           </a:p>
@@ -457,7 +457,7 @@
           <a:p>
             <a:fld id="{752E6B35-DAD5-CF47-9E65-9CA12B499D8C}" type="datetimeFigureOut">
               <a:rPr lang="en-US" smtClean="0"/>
-              <a:t>9/14/26</a:t>
+              <a:t>9/22/26</a:t>
             </a:fld>
             <a:endParaRPr lang="en-US"/>
           </a:p>
@@ -665,7 +665,7 @@
           <a:p>
             <a:fld id="{752E6B35-DAD5-CF47-9E65-9CA12B499D8C}" type="datetimeFigureOut">
               <a:rPr lang="en-US" smtClean="0"/>
-              <a:t>9/14/26</a:t>
+              <a:t>9/22/26</a:t>
             </a:fld>
             <a:endParaRPr lang="en-US"/>
           </a:p>
@@ -863,7 +863,7 @@
           <a:p>
             <a:fld id="{752E6B35-DAD5-CF47-9E65-9CA12B499D8C}" type="datetimeFigureOut">
               <a:rPr lang="en-US" smtClean="0"/>
-              <a:t>9/14/26</a:t>
+              <a:t>9/22/26</a:t>
             </a:fld>
             <a:endParaRPr lang="en-US"/>
           </a:p>
@@ -1138,7 +1138,7 @@
           <a:p>
             <a:fld id="{752E6B35-DAD5-CF47-9E65-9CA12B499D8C}" type="datetimeFigureOut">
               <a:rPr lang="en-US" smtClean="0"/>
-              <a:t>9/14/26</a:t>
+              <a:t>9/22/26</a:t>
             </a:fld>
             <a:endParaRPr lang="en-US"/>
           </a:p>
@@ -1403,7 +1403,7 @@
           <a:p>
             <a:fld id="{752E6B35-DAD5-CF47-9E65-9CA12B499D8C}" type="datetimeFigureOut">
               <a:rPr lang="en-US" smtClean="0"/>
-              <a:t>9/14/26</a:t>
+              <a:t>9/22/26</a:t>
             </a:fld>
             <a:endParaRPr lang="en-US"/>
           </a:p>
@@ -1815,7 +1815,7 @@
           <a:p>
             <a:fld id="{752E6B35-DAD5-CF47-9E65-9CA12B499D8C}" type="datetimeFigureOut">
               <a:rPr lang="en-US" smtClean="0"/>
-              <a:t>9/14/26</a:t>
+              <a:t>9/22/26</a:t>
             </a:fld>
             <a:endParaRPr lang="en-US"/>
           </a:p>
@@ -1956,7 +1956,7 @@
           <a:p>
             <a:fld id="{752E6B35-DAD5-CF47-9E65-9CA12B499D8C}" type="datetimeFigureOut">
               <a:rPr lang="en-US" smtClean="0"/>
-              <a:t>9/14/26</a:t>
+              <a:t>9/22/26</a:t>
             </a:fld>
             <a:endParaRPr lang="en-US"/>
           </a:p>
@@ -2069,7 +2069,7 @@
           <a:p>
             <a:fld id="{752E6B35-DAD5-CF47-9E65-9CA12B499D8C}" type="datetimeFigureOut">
               <a:rPr lang="en-US" smtClean="0"/>
-              <a:t>9/14/26</a:t>
+              <a:t>9/22/26</a:t>
             </a:fld>
             <a:endParaRPr lang="en-US"/>
           </a:p>
@@ -2380,7 +2380,7 @@
           <a:p>
             <a:fld id="{752E6B35-DAD5-CF47-9E65-9CA12B499D8C}" type="datetimeFigureOut">
               <a:rPr lang="en-US" smtClean="0"/>
-              <a:t>9/14/26</a:t>
+              <a:t>9/22/26</a:t>
             </a:fld>
             <a:endParaRPr lang="en-US"/>
           </a:p>
@@ -2668,7 +2668,7 @@
           <a:p>
             <a:fld id="{752E6B35-DAD5-CF47-9E65-9CA12B499D8C}" type="datetimeFigureOut">
               <a:rPr lang="en-US" smtClean="0"/>
-              <a:t>9/14/26</a:t>
+              <a:t>9/22/26</a:t>
             </a:fld>
             <a:endParaRPr lang="en-US"/>
           </a:p>
@@ -2909,7 +2909,7 @@
           <a:p>
             <a:fld id="{752E6B35-DAD5-CF47-9E65-9CA12B499D8C}" type="datetimeFigureOut">
               <a:rPr lang="en-US" smtClean="0"/>
-              <a:t>9/14/26</a:t>
+              <a:t>9/22/26</a:t>
             </a:fld>
             <a:endParaRPr lang="en-US"/>
           </a:p>
@@ -3391,19 +3391,15 @@
             <a:pPr lvl="1"/>
             <a:r>
               <a:rPr lang="en-US" dirty="0"/>
-              <a:t>Finalize the list of PCB requirements for the stationary testing system.​</a:t>
+              <a:t>Successfully connect and communicate with the LCD and camera using the Raspberry Pi Compute Module 5.</a:t>
             </a:r>
           </a:p>
           <a:p>
             <a:pPr lvl="1"/>
             <a:r>
               <a:rPr lang="en-US" dirty="0"/>
-              <a:t>Determine the major components, connections, and power requirements needed for PCB design.​</a:t>
-            </a:r>
-          </a:p>
-          <a:p>
-            <a:pPr lvl="1"/>
-            <a:endParaRPr lang="en-US" dirty="0"/>
+              <a:t>Integrate the LCD and camera with the machine learning model to display detected signs and corresponding commands.</a:t>
+            </a:r>
           </a:p>
           <a:p>
             <a:r>
@@ -3415,28 +3411,21 @@
             <a:pPr lvl="1"/>
             <a:r>
               <a:rPr lang="en-US" dirty="0"/>
-              <a:t>Completed the first-semester schematic for stationary testing of the autonomous car system.​</a:t>
+              <a:t>Prepared the necessary libraries and software for the LCD1602 RGB module.</a:t>
             </a:r>
           </a:p>
           <a:p>
             <a:pPr lvl="1"/>
             <a:r>
               <a:rPr lang="en-US" dirty="0"/>
-              <a:t>Built and refined the schematic around the Raspberry Pi Compute Module 5.​</a:t>
+              <a:t>Researched camera setup and configuration for the Raspberry Pi Compute Module 5.​​</a:t>
             </a:r>
           </a:p>
           <a:p>
             <a:pPr lvl="1"/>
             <a:r>
               <a:rPr lang="en-US" dirty="0"/>
-              <a:t>Resolved schematic/ERC issues and prepared the design for PCB development.​</a:t>
-            </a:r>
-          </a:p>
-          <a:p>
-            <a:pPr lvl="1"/>
-            <a:r>
-              <a:rPr lang="en-US" dirty="0"/>
-              <a:t>Began hardware prototyping for the stationary testing setup.​</a:t>
+              <a:t>Identified the steps needed to integrate the camera and LCD with the machine learning model.​​</a:t>
             </a:r>
           </a:p>
           <a:p>
@@ -3453,21 +3442,28 @@
             <a:pPr lvl="1"/>
             <a:r>
               <a:rPr lang="en-US" dirty="0"/>
-              <a:t>Begin the PCB design and layout using the completed schematic.​</a:t>
+              <a:t>Continue hardware testing and verify communication between the Raspberry Pi and all connected components.​​</a:t>
             </a:r>
           </a:p>
           <a:p>
             <a:pPr lvl="1"/>
             <a:r>
               <a:rPr lang="en-US" dirty="0"/>
-              <a:t>Start placing major components and determining board dimensions.​</a:t>
+              <a:t>Determine which components and connections will be included on the final PCB.​</a:t>
             </a:r>
           </a:p>
           <a:p>
             <a:pPr lvl="1"/>
             <a:r>
               <a:rPr lang="en-US" dirty="0"/>
-              <a:t>Begin planning power and signal routing.​</a:t>
+              <a:t>Begin planning the PCB layout, including component placement and board dimensions.​</a:t>
+            </a:r>
+          </a:p>
+          <a:p>
+            <a:pPr lvl="1"/>
+            <a:r>
+              <a:rPr lang="en-US" dirty="0"/>
+              <a:t>Begin planning power distribution and signal routing.​</a:t>
             </a:r>
           </a:p>
           <a:p>

</xml_diff>